<commit_message>
Add consulting-style slide source, video plan and recording script, README and process log
Co-Authored-By: Claude Opus 5.5 <noreply@anthropic.com>
</commit_message>
<xml_diff>
--- a/slides/secret_sauce.pptx
+++ b/slides/secret_sauce.pptx
@@ -3084,7 +3084,7 @@
     <p:bg>
       <p:bgPr>
         <a:solidFill>
-          <a:srgbClr val="FDF1DE"/>
+          <a:srgbClr val="F2F3F5"/>
         </a:solidFill>
         <a:effectLst/>
       </p:bgPr>
@@ -3126,9 +3126,9 @@
             <a:r>
               <a:rPr sz="1100" b="1">
                 <a:solidFill>
-                  <a:srgbClr val="E2701F"/>
-                </a:solidFill>
-                <a:latin typeface="Arial"/>
+                  <a:srgbClr val="EF6A00"/>
+                </a:solidFill>
+                <a:latin typeface="Barlow"/>
               </a:rPr>
               <a:t>THE SECRET SAUCE &amp; CORE INNOVATION</a:t>
             </a:r>
@@ -3165,9 +3165,9 @@
             <a:r>
               <a:rPr sz="2600" b="1">
                 <a:solidFill>
-                  <a:srgbClr val="16233A"/>
-                </a:solidFill>
-                <a:latin typeface="Arial"/>
+                  <a:srgbClr val="10214D"/>
+                </a:solidFill>
+                <a:latin typeface="Barlow"/>
               </a:rPr>
               <a:t>A signal only PNC can see, and answers only a family member would give in private</a:t>
             </a:r>
@@ -3195,7 +3195,7 @@
           </a:solidFill>
           <a:ln w="12700">
             <a:solidFill>
-              <a:srgbClr val="E6D8C2"/>
+              <a:srgbClr val="DDE0E4"/>
             </a:solidFill>
           </a:ln>
           <a:effectLst/>
@@ -3237,7 +3237,7 @@
             <a:avLst/>
           </a:prstGeom>
           <a:solidFill>
-            <a:srgbClr val="E2701F"/>
+            <a:srgbClr val="EF6A00"/>
           </a:solidFill>
           <a:ln>
             <a:noFill/>
@@ -3296,9 +3296,9 @@
             <a:r>
               <a:rPr sz="1500" b="1">
                 <a:solidFill>
-                  <a:srgbClr val="16233A"/>
-                </a:solidFill>
-                <a:latin typeface="Arial"/>
+                  <a:srgbClr val="10214D"/>
+                </a:solidFill>
+                <a:latin typeface="Barlow"/>
               </a:rPr>
               <a:t>1  Signal PNC already holds</a:t>
             </a:r>
@@ -3335,9 +3335,9 @@
             <a:r>
               <a:rPr sz="1050" b="0">
                 <a:solidFill>
-                  <a:srgbClr val="44566C"/>
-                </a:solidFill>
-                <a:latin typeface="Arial"/>
+                  <a:srgbClr val="5E646E"/>
+                </a:solidFill>
+                <a:latin typeface="Barlow"/>
               </a:rPr>
               <a:t>PNC banks the operating company. Payments to M&amp;A and valuation firms, audited-financials requests and early credit-line paydowns flag a likely sale 12–18 months before close.</a:t>
             </a:r>
@@ -3374,36 +3374,36 @@
             <a:r>
               <a:rPr sz="950" b="1">
                 <a:solidFill>
-                  <a:srgbClr val="E2701F"/>
-                </a:solidFill>
-                <a:latin typeface="Arial"/>
+                  <a:srgbClr val="EF6A00"/>
+                </a:solidFill>
+                <a:latin typeface="Barlow"/>
               </a:rPr>
               <a:t>AI: </a:t>
             </a:r>
             <a:r>
               <a:rPr sz="950" b="0">
                 <a:solidFill>
-                  <a:srgbClr val="16233A"/>
-                </a:solidFill>
-                <a:latin typeface="Arial"/>
+                  <a:srgbClr val="10214D"/>
+                </a:solidFill>
+                <a:latin typeface="Barlow"/>
               </a:rPr>
               <a:t>Gradient-boosted classifier scores likelihood and shows its top reasons</a:t>
             </a:r>
             <a:r>
               <a:rPr sz="950" b="1">
                 <a:solidFill>
-                  <a:srgbClr val="E2701F"/>
-                </a:solidFill>
-                <a:latin typeface="Arial"/>
+                  <a:srgbClr val="EF6A00"/>
+                </a:solidFill>
+                <a:latin typeface="Barlow"/>
               </a:rPr>
               <a:t>     Human: </a:t>
             </a:r>
             <a:r>
               <a:rPr sz="950" b="0">
                 <a:solidFill>
-                  <a:srgbClr val="16233A"/>
-                </a:solidFill>
-                <a:latin typeface="Arial"/>
+                  <a:srgbClr val="10214D"/>
+                </a:solidFill>
+                <a:latin typeface="Barlow"/>
               </a:rPr>
               <a:t>Advisor decides whether to call</a:t>
             </a:r>
@@ -3431,7 +3431,7 @@
           </a:solidFill>
           <a:ln w="12700">
             <a:solidFill>
-              <a:srgbClr val="E6D8C2"/>
+              <a:srgbClr val="DDE0E4"/>
             </a:solidFill>
           </a:ln>
           <a:effectLst/>
@@ -3473,7 +3473,7 @@
             <a:avLst/>
           </a:prstGeom>
           <a:solidFill>
-            <a:srgbClr val="6A5A8E"/>
+            <a:srgbClr val="6D4AA0"/>
           </a:solidFill>
           <a:ln>
             <a:noFill/>
@@ -3532,9 +3532,9 @@
             <a:r>
               <a:rPr sz="1500" b="1">
                 <a:solidFill>
-                  <a:srgbClr val="16233A"/>
-                </a:solidFill>
-                <a:latin typeface="Arial"/>
+                  <a:srgbClr val="10214D"/>
+                </a:solidFill>
+                <a:latin typeface="Barlow"/>
               </a:rPr>
               <a:t>2  Private-by-default family alignment</a:t>
             </a:r>
@@ -3571,9 +3571,9 @@
             <a:r>
               <a:rPr sz="1050" b="0">
                 <a:solidFill>
-                  <a:srgbClr val="44566C"/>
-                </a:solidFill>
-                <a:latin typeface="Arial"/>
+                  <a:srgbClr val="5E646E"/>
+                </a:solidFill>
+                <a:latin typeface="Barlow"/>
               </a:rPr>
               <a:t>Each family member checks in alone. A language model tags answers into six themes; a fixed formula scores where members disagree. Advisor sees the gap, never the words, unless that person shares.</a:t>
             </a:r>
@@ -3610,36 +3610,36 @@
             <a:r>
               <a:rPr sz="950" b="1">
                 <a:solidFill>
-                  <a:srgbClr val="6A5A8E"/>
-                </a:solidFill>
-                <a:latin typeface="Arial"/>
+                  <a:srgbClr val="6D4AA0"/>
+                </a:solidFill>
+                <a:latin typeface="Barlow"/>
               </a:rPr>
               <a:t>AI: </a:t>
             </a:r>
             <a:r>
               <a:rPr sz="950" b="0">
                 <a:solidFill>
-                  <a:srgbClr val="16233A"/>
-                </a:solidFill>
-                <a:latin typeface="Arial"/>
+                  <a:srgbClr val="10214D"/>
+                </a:solidFill>
+                <a:latin typeface="Barlow"/>
               </a:rPr>
               <a:t>LLM extracts stances; divergence = spread of stances (no model)</a:t>
             </a:r>
             <a:r>
               <a:rPr sz="950" b="1">
                 <a:solidFill>
-                  <a:srgbClr val="6A5A8E"/>
-                </a:solidFill>
-                <a:latin typeface="Arial"/>
+                  <a:srgbClr val="6D4AA0"/>
+                </a:solidFill>
+                <a:latin typeface="Barlow"/>
               </a:rPr>
               <a:t>     Human: </a:t>
             </a:r>
             <a:r>
               <a:rPr sz="950" b="0">
                 <a:solidFill>
-                  <a:srgbClr val="16233A"/>
-                </a:solidFill>
-                <a:latin typeface="Arial"/>
+                  <a:srgbClr val="10214D"/>
+                </a:solidFill>
+                <a:latin typeface="Barlow"/>
               </a:rPr>
               <a:t>Each member decides what is shared</a:t>
             </a:r>
@@ -3667,7 +3667,7 @@
           </a:solidFill>
           <a:ln w="12700">
             <a:solidFill>
-              <a:srgbClr val="E6D8C2"/>
+              <a:srgbClr val="DDE0E4"/>
             </a:solidFill>
           </a:ln>
           <a:effectLst/>
@@ -3709,7 +3709,7 @@
             <a:avLst/>
           </a:prstGeom>
           <a:solidFill>
-            <a:srgbClr val="4F8571"/>
+            <a:srgbClr val="6F9A4B"/>
           </a:solidFill>
           <a:ln>
             <a:noFill/>
@@ -3768,9 +3768,9 @@
             <a:r>
               <a:rPr sz="1500" b="1">
                 <a:solidFill>
-                  <a:srgbClr val="16233A"/>
-                </a:solidFill>
-                <a:latin typeface="Arial"/>
+                  <a:srgbClr val="10214D"/>
+                </a:solidFill>
+                <a:latin typeface="Barlow"/>
               </a:rPr>
               <a:t>3  One household graph</a:t>
             </a:r>
@@ -3807,9 +3807,9 @@
             <a:r>
               <a:rPr sz="1050" b="0">
                 <a:solidFill>
-                  <a:srgbClr val="44566C"/>
-                </a:solidFill>
-                <a:latin typeface="Arial"/>
+                  <a:srgbClr val="5E646E"/>
+                </a:solidFill>
+                <a:latin typeface="Barlow"/>
               </a:rPr>
               <a:t>Business ↔ owners ↔ spouse ↔ heirs ↔ trusts ↔ accounts, with consent attached to every link. Heirs become PNC relationships before any assets move.</a:t>
             </a:r>
@@ -3846,36 +3846,36 @@
             <a:r>
               <a:rPr sz="950" b="1">
                 <a:solidFill>
-                  <a:srgbClr val="4F8571"/>
-                </a:solidFill>
-                <a:latin typeface="Arial"/>
+                  <a:srgbClr val="6F9A4B"/>
+                </a:solidFill>
+                <a:latin typeface="Barlow"/>
               </a:rPr>
               <a:t>AI: </a:t>
             </a:r>
             <a:r>
               <a:rPr sz="950" b="0">
                 <a:solidFill>
-                  <a:srgbClr val="16233A"/>
-                </a:solidFill>
-                <a:latin typeface="Arial"/>
+                  <a:srgbClr val="10214D"/>
+                </a:solidFill>
+                <a:latin typeface="Barlow"/>
               </a:rPr>
               <a:t>Graph built from existing PNC records plus invites</a:t>
             </a:r>
             <a:r>
               <a:rPr sz="950" b="1">
                 <a:solidFill>
-                  <a:srgbClr val="4F8571"/>
-                </a:solidFill>
-                <a:latin typeface="Arial"/>
+                  <a:srgbClr val="6F9A4B"/>
+                </a:solidFill>
+                <a:latin typeface="Barlow"/>
               </a:rPr>
               <a:t>     Human: </a:t>
             </a:r>
             <a:r>
               <a:rPr sz="950" b="0">
                 <a:solidFill>
-                  <a:srgbClr val="16233A"/>
-                </a:solidFill>
-                <a:latin typeface="Arial"/>
+                  <a:srgbClr val="10214D"/>
+                </a:solidFill>
+                <a:latin typeface="Barlow"/>
               </a:rPr>
               <a:t>Family approves; advisor routes specialists</a:t>
             </a:r>
@@ -3899,7 +3899,7 @@
             </a:avLst>
           </a:prstGeom>
           <a:solidFill>
-            <a:srgbClr val="16233A"/>
+            <a:srgbClr val="10214D"/>
           </a:solidFill>
           <a:ln>
             <a:noFill/>
@@ -3960,7 +3960,7 @@
                 <a:solidFill>
                   <a:srgbClr val="FFFFFF"/>
                 </a:solidFill>
-                <a:latin typeface="Arial"/>
+                <a:latin typeface="Barlow"/>
               </a:rPr>
               <a:t>Who sees what</a:t>
             </a:r>
@@ -3999,7 +3999,7 @@
                 <a:solidFill>
                   <a:srgbClr val="C9D0D8"/>
                 </a:solidFill>
-                <a:latin typeface="Arial"/>
+                <a:latin typeface="Barlow"/>
               </a:rPr>
               <a:t>Member</a:t>
             </a:r>
@@ -4038,7 +4038,7 @@
                 <a:solidFill>
                   <a:srgbClr val="C9D0D8"/>
                 </a:solidFill>
-                <a:latin typeface="Arial"/>
+                <a:latin typeface="Barlow"/>
               </a:rPr>
               <a:t>Family</a:t>
             </a:r>
@@ -4077,7 +4077,7 @@
                 <a:solidFill>
                   <a:srgbClr val="C9D0D8"/>
                 </a:solidFill>
-                <a:latin typeface="Arial"/>
+                <a:latin typeface="Barlow"/>
               </a:rPr>
               <a:t>Advisor</a:t>
             </a:r>
@@ -4101,7 +4101,7 @@
             </a:avLst>
           </a:prstGeom>
           <a:solidFill>
-            <a:srgbClr val="22314B"/>
+            <a:srgbClr val="1A2B5C"/>
           </a:solidFill>
           <a:ln>
             <a:noFill/>
@@ -4162,7 +4162,7 @@
                 <a:solidFill>
                   <a:srgbClr val="FFFFFF"/>
                 </a:solidFill>
-                <a:latin typeface="Arial"/>
+                <a:latin typeface="Barlow"/>
               </a:rPr>
               <a:t>Raw answer text</a:t>
             </a:r>
@@ -4201,7 +4201,7 @@
                 <a:solidFill>
                   <a:srgbClr val="FFFFFF"/>
                 </a:solidFill>
-                <a:latin typeface="Arial"/>
+                <a:latin typeface="Barlow"/>
               </a:rPr>
               <a:t>✓</a:t>
             </a:r>
@@ -4240,7 +4240,7 @@
                 <a:solidFill>
                   <a:srgbClr val="8A97A8"/>
                 </a:solidFill>
-                <a:latin typeface="Arial"/>
+                <a:latin typeface="Barlow"/>
               </a:rPr>
               <a:t>—</a:t>
             </a:r>
@@ -4277,9 +4277,9 @@
             <a:r>
               <a:rPr sz="900" b="1">
                 <a:solidFill>
-                  <a:srgbClr val="E2701F"/>
-                </a:solidFill>
-                <a:latin typeface="Arial"/>
+                  <a:srgbClr val="EF6A00"/>
+                </a:solidFill>
+                <a:latin typeface="Barlow"/>
               </a:rPr>
               <a:t>if shared</a:t>
             </a:r>
@@ -4303,7 +4303,7 @@
             </a:avLst>
           </a:prstGeom>
           <a:solidFill>
-            <a:srgbClr val="22314B"/>
+            <a:srgbClr val="1A2B5C"/>
           </a:solidFill>
           <a:ln>
             <a:noFill/>
@@ -4364,7 +4364,7 @@
                 <a:solidFill>
                   <a:srgbClr val="FFFFFF"/>
                 </a:solidFill>
-                <a:latin typeface="Arial"/>
+                <a:latin typeface="Barlow"/>
               </a:rPr>
               <a:t>Theme stances</a:t>
             </a:r>
@@ -4403,7 +4403,7 @@
                 <a:solidFill>
                   <a:srgbClr val="FFFFFF"/>
                 </a:solidFill>
-                <a:latin typeface="Arial"/>
+                <a:latin typeface="Barlow"/>
               </a:rPr>
               <a:t>✓</a:t>
             </a:r>
@@ -4442,7 +4442,7 @@
                 <a:solidFill>
                   <a:srgbClr val="8A97A8"/>
                 </a:solidFill>
-                <a:latin typeface="Arial"/>
+                <a:latin typeface="Barlow"/>
               </a:rPr>
               <a:t>—</a:t>
             </a:r>
@@ -4481,7 +4481,7 @@
                 <a:solidFill>
                   <a:srgbClr val="8A97A8"/>
                 </a:solidFill>
-                <a:latin typeface="Arial"/>
+                <a:latin typeface="Barlow"/>
               </a:rPr>
               <a:t>—</a:t>
             </a:r>
@@ -4505,7 +4505,7 @@
             </a:avLst>
           </a:prstGeom>
           <a:solidFill>
-            <a:srgbClr val="22314B"/>
+            <a:srgbClr val="1A2B5C"/>
           </a:solidFill>
           <a:ln>
             <a:noFill/>
@@ -4566,7 +4566,7 @@
                 <a:solidFill>
                   <a:srgbClr val="FFFFFF"/>
                 </a:solidFill>
-                <a:latin typeface="Arial"/>
+                <a:latin typeface="Barlow"/>
               </a:rPr>
               <a:t>Gap score per theme</a:t>
             </a:r>
@@ -4605,7 +4605,7 @@
                 <a:solidFill>
                   <a:srgbClr val="FFFFFF"/>
                 </a:solidFill>
-                <a:latin typeface="Arial"/>
+                <a:latin typeface="Barlow"/>
               </a:rPr>
               <a:t>✓</a:t>
             </a:r>
@@ -4644,7 +4644,7 @@
                 <a:solidFill>
                   <a:srgbClr val="8A97A8"/>
                 </a:solidFill>
-                <a:latin typeface="Arial"/>
+                <a:latin typeface="Barlow"/>
               </a:rPr>
               <a:t>—</a:t>
             </a:r>
@@ -4683,7 +4683,7 @@
                 <a:solidFill>
                   <a:srgbClr val="FFFFFF"/>
                 </a:solidFill>
-                <a:latin typeface="Arial"/>
+                <a:latin typeface="Barlow"/>
               </a:rPr>
               <a:t>✓</a:t>
             </a:r>
@@ -4707,7 +4707,7 @@
             </a:avLst>
           </a:prstGeom>
           <a:solidFill>
-            <a:srgbClr val="22314B"/>
+            <a:srgbClr val="1A2B5C"/>
           </a:solidFill>
           <a:ln>
             <a:noFill/>
@@ -4768,7 +4768,7 @@
                 <a:solidFill>
                   <a:srgbClr val="FFFFFF"/>
                 </a:solidFill>
-                <a:latin typeface="Arial"/>
+                <a:latin typeface="Barlow"/>
               </a:rPr>
               <a:t>“Has checked in”</a:t>
             </a:r>
@@ -4807,7 +4807,7 @@
                 <a:solidFill>
                   <a:srgbClr val="FFFFFF"/>
                 </a:solidFill>
-                <a:latin typeface="Arial"/>
+                <a:latin typeface="Barlow"/>
               </a:rPr>
               <a:t>✓</a:t>
             </a:r>
@@ -4846,7 +4846,7 @@
                 <a:solidFill>
                   <a:srgbClr val="FFFFFF"/>
                 </a:solidFill>
-                <a:latin typeface="Arial"/>
+                <a:latin typeface="Barlow"/>
               </a:rPr>
               <a:t>✓</a:t>
             </a:r>
@@ -4885,7 +4885,7 @@
                 <a:solidFill>
                   <a:srgbClr val="FFFFFF"/>
                 </a:solidFill>
-                <a:latin typeface="Arial"/>
+                <a:latin typeface="Barlow"/>
               </a:rPr>
               <a:t>✓</a:t>
             </a:r>
@@ -4909,7 +4909,7 @@
             </a:avLst>
           </a:prstGeom>
           <a:solidFill>
-            <a:srgbClr val="22314B"/>
+            <a:srgbClr val="1A2B5C"/>
           </a:solidFill>
           <a:ln>
             <a:noFill/>
@@ -4970,7 +4970,7 @@
                 <a:solidFill>
                   <a:srgbClr val="FFFFFF"/>
                 </a:solidFill>
-                <a:latin typeface="Arial"/>
+                <a:latin typeface="Barlow"/>
               </a:rPr>
               <a:t>Sale-likelihood reasons</a:t>
             </a:r>
@@ -5009,7 +5009,7 @@
                 <a:solidFill>
                   <a:srgbClr val="8A97A8"/>
                 </a:solidFill>
-                <a:latin typeface="Arial"/>
+                <a:latin typeface="Barlow"/>
               </a:rPr>
               <a:t>—</a:t>
             </a:r>
@@ -5048,7 +5048,7 @@
                 <a:solidFill>
                   <a:srgbClr val="8A97A8"/>
                 </a:solidFill>
-                <a:latin typeface="Arial"/>
+                <a:latin typeface="Barlow"/>
               </a:rPr>
               <a:t>—</a:t>
             </a:r>
@@ -5087,7 +5087,7 @@
                 <a:solidFill>
                   <a:srgbClr val="FFFFFF"/>
                 </a:solidFill>
-                <a:latin typeface="Arial"/>
+                <a:latin typeface="Barlow"/>
               </a:rPr>
               <a:t>✓</a:t>
             </a:r>
@@ -5115,7 +5115,7 @@
           </a:solidFill>
           <a:ln w="12700">
             <a:solidFill>
-              <a:srgbClr val="E6D8C2"/>
+              <a:srgbClr val="DDE0E4"/>
             </a:solidFill>
           </a:ln>
           <a:effectLst/>
@@ -5172,9 +5172,9 @@
             <a:r>
               <a:rPr sz="1250" b="1">
                 <a:solidFill>
-                  <a:srgbClr val="16233A"/>
-                </a:solidFill>
-                <a:latin typeface="Arial"/>
+                  <a:srgbClr val="10214D"/>
+                </a:solidFill>
+                <a:latin typeface="Barlow"/>
               </a:rPr>
               <a:t>Why competitors struggle to copy it</a:t>
             </a:r>
@@ -5211,18 +5211,18 @@
             <a:r>
               <a:rPr sz="950" b="1">
                 <a:solidFill>
-                  <a:srgbClr val="E2701F"/>
-                </a:solidFill>
-                <a:latin typeface="Arial"/>
+                  <a:srgbClr val="EF6A00"/>
+                </a:solidFill>
+                <a:latin typeface="Barlow"/>
               </a:rPr>
               <a:t>Timing. </a:t>
             </a:r>
             <a:r>
               <a:rPr sz="950" b="0">
                 <a:solidFill>
-                  <a:srgbClr val="44566C"/>
-                </a:solidFill>
-                <a:latin typeface="Arial"/>
+                  <a:srgbClr val="5E646E"/>
+                </a:solidFill>
+                <a:latin typeface="Barlow"/>
               </a:rPr>
               <a:t>RIAs and wirehouses see the money after it moves; PNC sees the business before it sells.</a:t>
             </a:r>
@@ -5236,18 +5236,18 @@
             <a:r>
               <a:rPr sz="950" b="1">
                 <a:solidFill>
-                  <a:srgbClr val="6A5A8E"/>
-                </a:solidFill>
-                <a:latin typeface="Arial"/>
+                  <a:srgbClr val="6D4AA0"/>
+                </a:solidFill>
+                <a:latin typeface="Barlow"/>
               </a:rPr>
               <a:t>Trust. </a:t>
             </a:r>
             <a:r>
               <a:rPr sz="950" b="0">
                 <a:solidFill>
-                  <a:srgbClr val="44566C"/>
-                </a:solidFill>
-                <a:latin typeface="Arial"/>
+                  <a:srgbClr val="5E646E"/>
+                </a:solidFill>
+                <a:latin typeface="Barlow"/>
               </a:rPr>
               <a:t>Honest, private answers build up per family and can't be scraped or bought.</a:t>
             </a:r>
@@ -5261,18 +5261,18 @@
             <a:r>
               <a:rPr sz="950" b="1">
                 <a:solidFill>
-                  <a:srgbClr val="4F8571"/>
-                </a:solidFill>
-                <a:latin typeface="Arial"/>
+                  <a:srgbClr val="6F9A4B"/>
+                </a:solidFill>
+                <a:latin typeface="Barlow"/>
               </a:rPr>
               <a:t>One roof. </a:t>
             </a:r>
             <a:r>
               <a:rPr sz="950" b="0">
                 <a:solidFill>
-                  <a:srgbClr val="44566C"/>
-                </a:solidFill>
-                <a:latin typeface="Arial"/>
+                  <a:srgbClr val="5E646E"/>
+                </a:solidFill>
+                <a:latin typeface="Barlow"/>
               </a:rPr>
               <a:t>Commercial banking, Private Bank and Hawthorn IFS already sit inside PNC.</a:t>
             </a:r>
@@ -5309,9 +5309,9 @@
             <a:r>
               <a:rPr sz="850" b="0">
                 <a:solidFill>
-                  <a:srgbClr val="44566C"/>
-                </a:solidFill>
-                <a:latin typeface="Arial"/>
+                  <a:srgbClr val="5E646E"/>
+                </a:solidFill>
+                <a:latin typeface="Barlow"/>
               </a:rPr>
               <a:t>Rule: fixed formulas calculate every number; language models only explain them; an advisor approves every output before a client sees it. Signal use must be validated against PNC data-sharing and consent policies.</a:t>
             </a:r>

</xml_diff>